<commit_message>
Synchronize published status, reports, deck and independently accepted FP32 demo
</commit_message>
<xml_diff>
--- a/presentation/PathMNIST_AI工程实践汇报_教师提交版.pptx
+++ b/presentation/PathMNIST_AI工程实践汇报_教师提交版.pptx
@@ -815,7 +815,7 @@
           </a:p>
           <a:p>
             <a:r>
-              <a:t>历史实验来自固定提交d5e4a71；本轮只重组文稿与执行交付文件检查，不训练或推理官方测试。</a:t>
+              <a:t>科学实验来自固定提交d5e4a71；发布阶段另验固定验证样例与文件，不训练或推理官方测试。</a:t>
             </a:r>
           </a:p>
         </p:txBody>
@@ -956,7 +956,7 @@
           </a:p>
           <a:p>
             <a:r>
-              <a:t>历史实验来自固定提交d5e4a71；本轮只重组文稿与执行交付文件检查，不训练或推理官方测试。</a:t>
+              <a:t>科学实验来自固定提交d5e4a71；发布阶段另验固定验证样例与文件，不训练或推理官方测试。</a:t>
             </a:r>
           </a:p>
         </p:txBody>
@@ -1097,7 +1097,7 @@
           </a:p>
           <a:p>
             <a:r>
-              <a:t>历史实验来自固定提交d5e4a71；本轮只重组文稿与执行交付文件检查，不训练或推理官方测试。</a:t>
+              <a:t>科学实验来自固定提交d5e4a71；发布阶段另验固定验证样例与文件，不训练或推理官方测试。</a:t>
             </a:r>
           </a:p>
         </p:txBody>
@@ -1238,7 +1238,7 @@
           </a:p>
           <a:p>
             <a:r>
-              <a:t>历史实验来自固定提交d5e4a71；本轮只重组文稿与执行交付文件检查，不训练或推理官方测试。</a:t>
+              <a:t>科学实验来自固定提交d5e4a71；发布阶段另验固定验证样例与文件，不训练或推理官方测试。</a:t>
             </a:r>
           </a:p>
         </p:txBody>
@@ -1379,7 +1379,7 @@
           </a:p>
           <a:p>
             <a:r>
-              <a:t>历史实验来自固定提交d5e4a71；本轮只重组文稿与执行交付文件检查，不训练或推理官方测试。</a:t>
+              <a:t>科学实验来自固定提交d5e4a71；发布阶段另验固定验证样例与文件，不训练或推理官方测试。</a:t>
             </a:r>
           </a:p>
         </p:txBody>
@@ -1520,7 +1520,7 @@
           </a:p>
           <a:p>
             <a:r>
-              <a:t>历史实验来自固定提交d5e4a71；本轮只重组文稿与执行交付文件检查，不训练或推理官方测试。</a:t>
+              <a:t>科学实验来自固定提交d5e4a71；发布阶段另验固定验证样例与文件，不训练或推理官方测试。</a:t>
             </a:r>
           </a:p>
         </p:txBody>
@@ -1661,7 +1661,7 @@
           </a:p>
           <a:p>
             <a:r>
-              <a:t>历史实验来自固定提交d5e4a71；本轮只重组文稿与执行交付文件检查，不训练或推理官方测试。</a:t>
+              <a:t>科学实验来自固定提交d5e4a71；发布阶段另验固定验证样例与文件，不训练或推理官方测试。</a:t>
             </a:r>
           </a:p>
         </p:txBody>
@@ -1802,7 +1802,7 @@
           </a:p>
           <a:p>
             <a:r>
-              <a:t>历史实验来自固定提交d5e4a71；本轮只重组文稿与执行交付文件检查，不训练或推理官方测试。</a:t>
+              <a:t>科学实验来自固定提交d5e4a71；发布阶段另验固定验证样例与文件，不训练或推理官方测试。</a:t>
             </a:r>
           </a:p>
         </p:txBody>
@@ -1943,7 +1943,7 @@
           </a:p>
           <a:p>
             <a:r>
-              <a:t>历史实验来自固定提交d5e4a71；本轮只重组文稿与执行交付文件检查，不训练或推理官方测试。</a:t>
+              <a:t>科学实验来自固定提交d5e4a71；发布阶段另验固定验证样例与文件，不训练或推理官方测试。</a:t>
             </a:r>
           </a:p>
         </p:txBody>
@@ -2084,7 +2084,7 @@
           </a:p>
           <a:p>
             <a:r>
-              <a:t>历史实验来自固定提交d5e4a71；本轮只重组文稿与执行交付文件检查，不训练或推理官方测试。</a:t>
+              <a:t>科学实验来自固定提交d5e4a71；发布阶段另验固定验证样例与文件，不训练或推理官方测试。</a:t>
             </a:r>
           </a:p>
         </p:txBody>
@@ -2225,7 +2225,7 @@
           </a:p>
           <a:p>
             <a:r>
-              <a:t>历史实验来自固定提交d5e4a71；本轮只重组文稿与执行交付文件检查，不训练或推理官方测试。</a:t>
+              <a:t>科学实验来自固定提交d5e4a71；发布阶段另验固定验证样例与文件，不训练或推理官方测试。</a:t>
             </a:r>
           </a:p>
         </p:txBody>
@@ -2366,7 +2366,7 @@
           </a:p>
           <a:p>
             <a:r>
-              <a:t>历史实验来自固定提交d5e4a71；本轮只重组文稿与执行交付文件检查，不训练或推理官方测试。</a:t>
+              <a:t>科学实验来自固定提交d5e4a71；发布阶段另验固定验证样例与文件，不训练或推理官方测试。</a:t>
             </a:r>
           </a:p>
         </p:txBody>
@@ -2507,7 +2507,7 @@
           </a:p>
           <a:p>
             <a:r>
-              <a:t>历史实验来自固定提交d5e4a71；本轮只重组文稿与执行交付文件检查，不训练或推理官方测试。</a:t>
+              <a:t>科学实验来自固定提交d5e4a71；发布阶段另验固定验证样例与文件，不训练或推理官方测试。</a:t>
             </a:r>
           </a:p>
         </p:txBody>
@@ -2604,7 +2604,7 @@
           </a:p>
           <a:p>
             <a:r>
-              <a:t>FP32 ONNX本身就可以本地推理，不需要先量化。历史程序已在Mac依赖安装后断网检查，包含真实样例和异常输入。当前教师目录已整理代码，模型和固定PNG要从原归档复制后才能运行；不能把这份整理包当成已经新验收的演示。</a:t>
+              <a:t>FP32 ONNX本身就可以本地推理，不需要先量化。发布接手从原归档补齐模型和10张固定PNG，并逐个核对哈希。新副本在独立Mac环境完成20项运行检查和4项浏览器验收。命令行由操作系统禁止外网；界面服务仅允许本机回环，浏览器未全局断网。右图仍为历史截图，新记录单独保留。</a:t>
             </a:r>
           </a:p>
           <a:p/>
@@ -2648,7 +2648,7 @@
           </a:p>
           <a:p>
             <a:r>
-              <a:t>历史实验来自固定提交d5e4a71；本轮只重组文稿与执行交付文件检查，不训练或推理官方测试。</a:t>
+              <a:t>科学实验来自固定提交d5e4a71；发布阶段另验固定验证样例与文件，不训练或推理官方测试。</a:t>
             </a:r>
           </a:p>
         </p:txBody>
@@ -2723,7 +2723,7 @@
           </a:p>
           <a:p>
             <a:r>
-              <a:t>实现用户批准的独立仓库规划，不冒称云端操作已发生。</a:t>
+              <a:t>说明已完成的独立私有发布，以及仍待确认的教师权限。</a:t>
             </a:r>
           </a:p>
           <a:p/>
@@ -2745,7 +2745,7 @@
           </a:p>
           <a:p>
             <a:r>
-              <a:t>原仓库继续保留历史，我们另建教师导向的提交目录，把最新文件和必要证据集中。新库自己的版本记录文稿变化，原d5记录科学依据。当前连接没有写入接口，所以云端创建和CI还待Codex完成，不用成功徽章冒充已发布。</a:t>
+              <a:t>独立私有仓库Wenhow1/pathmnist-ai-practice-submission已创建并上传，原仓库保持只读。新库包含报告、PPT、必要代码、证据、模型和固定样例，基本阅读与演示不依赖原私有库权限。真实CI已有通过记录，具体提交与Release见发布回执。教师账号未提供，因此尚未邀请或验收教师访问。</a:t>
             </a:r>
           </a:p>
           <a:p/>
@@ -2767,7 +2767,7 @@
           </a:p>
           <a:p>
             <a:r>
-              <a:t>问：老师需要原库权限吗？答：基本阅读与演示应在新库提供必要材料；源引用不作为唯一下载路径，发布时需复制演示资产。</a:t>
+              <a:t>问：老师需要原库权限吗？答：基本阅读与演示所需资产已在新库；老师仍需获得新私有库权限并接受邀请。</a:t>
             </a:r>
           </a:p>
           <a:p/>
@@ -2789,7 +2789,7 @@
           </a:p>
           <a:p>
             <a:r>
-              <a:t>历史实验来自固定提交d5e4a71；本轮只重组文稿与执行交付文件检查，不训练或推理官方测试。</a:t>
+              <a:t>科学实验来自固定提交d5e4a71；发布阶段另验固定验证样例与文件，不训练或推理官方测试。</a:t>
             </a:r>
           </a:p>
         </p:txBody>
@@ -2886,7 +2886,7 @@
           </a:p>
           <a:p>
             <a:r>
-              <a:t>已有的CLI和审计脚本使任务可以重复执行，恢复与演示是独立模块。我们没有项目专用Skill的历史调用记录，因此不列成成果。当前增加的是教师提交检查，云端CI要真正运行后才能记成功，不能倒填到原实验阶段。</a:t>
+              <a:t>已有CLI、审计脚本、恢复原型和演示模块可以复用。没有项目专用Skill的历史调用记录，因此不倒填经历。提交阶段新增的CI已经真实通过，运行21项提交检查器单元测试，并严格检查文件、运行资产哈希和保存结果算术；它不训练或加载模型。新副本模型行为另外验收，两类结果分开记录。</a:t>
             </a:r>
           </a:p>
           <a:p/>
@@ -2930,7 +2930,7 @@
           </a:p>
           <a:p>
             <a:r>
-              <a:t>历史实验来自固定提交d5e4a71；本轮只重组文稿与执行交付文件检查，不训练或推理官方测试。</a:t>
+              <a:t>科学实验来自固定提交d5e4a71；发布阶段另验固定验证样例与文件，不训练或推理官方测试。</a:t>
             </a:r>
           </a:p>
         </p:txBody>
@@ -3071,7 +3071,7 @@
           </a:p>
           <a:p>
             <a:r>
-              <a:t>历史实验来自固定提交d5e4a71；本轮只重组文稿与执行交付文件检查，不训练或推理官方测试。</a:t>
+              <a:t>科学实验来自固定提交d5e4a71；发布阶段另验固定验证样例与文件，不训练或推理官方测试。</a:t>
             </a:r>
           </a:p>
         </p:txBody>
@@ -3168,7 +3168,7 @@
           </a:p>
           <a:p>
             <a:r>
-              <a:t>我们把自然语言需求推进成代码、真实实验、核查和交付，并保留AI建议被纠正或否决的过程。分类只是载体，核心是能解释每项检查和取舍。患者级、全平台以及新云端发布等尚无证据的内容仍如实保留。</a:t>
+              <a:t>我们把自然语言需求推进成代码、真实实验、核查和交付，并保留建议被纠正或否决的过程。发布接手补齐原运行资产、验收新副本，创建独立私有库并取得真实CI记录。科学结果没有改变。患者级、全平台、教师账号访问和课堂设备仍保留证据边界。</a:t>
             </a:r>
           </a:p>
           <a:p/>
@@ -3212,7 +3212,7 @@
           </a:p>
           <a:p>
             <a:r>
-              <a:t>历史实验来自固定提交d5e4a71；本轮只重组文稿与执行交付文件检查，不训练或推理官方测试。</a:t>
+              <a:t>科学实验来自固定提交d5e4a71；发布阶段另验固定验证样例与文件，不训练或推理官方测试。</a:t>
             </a:r>
           </a:p>
         </p:txBody>
@@ -3353,7 +3353,7 @@
           </a:p>
           <a:p>
             <a:r>
-              <a:t>历史实验来自固定提交d5e4a71；本轮只重组文稿与执行交付文件检查，不训练或推理官方测试。</a:t>
+              <a:t>科学实验来自固定提交d5e4a71；发布阶段另验固定验证样例与文件，不训练或推理官方测试。</a:t>
             </a:r>
           </a:p>
         </p:txBody>
@@ -3494,7 +3494,7 @@
           </a:p>
           <a:p>
             <a:r>
-              <a:t>历史实验来自固定提交d5e4a71；本轮只重组文稿与执行交付文件检查，不训练或推理官方测试。</a:t>
+              <a:t>科学实验来自固定提交d5e4a71；发布阶段另验固定验证样例与文件，不训练或推理官方测试。</a:t>
             </a:r>
           </a:p>
         </p:txBody>
@@ -3635,7 +3635,7 @@
           </a:p>
           <a:p>
             <a:r>
-              <a:t>历史实验来自固定提交d5e4a71；本轮只重组文稿与执行交付文件检查，不训练或推理官方测试。</a:t>
+              <a:t>科学实验来自固定提交d5e4a71；发布阶段另验固定验证样例与文件，不训练或推理官方测试。</a:t>
             </a:r>
           </a:p>
         </p:txBody>
@@ -3776,7 +3776,7 @@
           </a:p>
           <a:p>
             <a:r>
-              <a:t>历史实验来自固定提交d5e4a71；本轮只重组文稿与执行交付文件检查，不训练或推理官方测试。</a:t>
+              <a:t>科学实验来自固定提交d5e4a71；发布阶段另验固定验证样例与文件，不训练或推理官方测试。</a:t>
             </a:r>
           </a:p>
         </p:txBody>
@@ -3917,7 +3917,7 @@
           </a:p>
           <a:p>
             <a:r>
-              <a:t>历史实验来自固定提交d5e4a71；本轮只重组文稿与执行交付文件检查，不训练或推理官方测试。</a:t>
+              <a:t>科学实验来自固定提交d5e4a71；发布阶段另验固定验证样例与文件，不训练或推理官方测试。</a:t>
             </a:r>
           </a:p>
         </p:txBody>
@@ -4058,7 +4058,7 @@
           </a:p>
           <a:p>
             <a:r>
-              <a:t>历史实验来自固定提交d5e4a71；本轮只重组文稿与执行交付文件检查，不训练或推理官方测试。</a:t>
+              <a:t>科学实验来自固定提交d5e4a71；发布阶段另验固定验证样例与文件，不训练或推理官方测试。</a:t>
             </a:r>
           </a:p>
         </p:txBody>
@@ -4199,7 +4199,7 @@
           </a:p>
           <a:p>
             <a:r>
-              <a:t>历史实验来自固定提交d5e4a71；本轮只重组文稿与执行交付文件检查，不训练或推理官方测试。</a:t>
+              <a:t>科学实验来自固定提交d5e4a71；发布阶段另验固定验证样例与文件，不训练或推理官方测试。</a:t>
             </a:r>
           </a:p>
         </p:txBody>
@@ -4340,7 +4340,7 @@
           </a:p>
           <a:p>
             <a:r>
-              <a:t>历史实验来自固定提交d5e4a71；本轮只重组文稿与执行交付文件检查，不训练或推理官方测试。</a:t>
+              <a:t>科学实验来自固定提交d5e4a71；发布阶段另验固定验证样例与文件，不训练或推理官方测试。</a:t>
             </a:r>
           </a:p>
         </p:txBody>
@@ -4481,7 +4481,7 @@
           </a:p>
           <a:p>
             <a:r>
-              <a:t>历史实验来自固定提交d5e4a71；本轮只重组文稿与执行交付文件检查，不训练或推理官方测试。</a:t>
+              <a:t>科学实验来自固定提交d5e4a71；发布阶段另验固定验证样例与文件，不训练或推理官方测试。</a:t>
             </a:r>
           </a:p>
         </p:txBody>
@@ -4622,7 +4622,7 @@
           </a:p>
           <a:p>
             <a:r>
-              <a:t>历史实验来自固定提交d5e4a71；本轮只重组文稿与执行交付文件检查，不训练或推理官方测试。</a:t>
+              <a:t>科学实验来自固定提交d5e4a71；发布阶段另验固定验证样例与文件，不训练或推理官方测试。</a:t>
             </a:r>
           </a:p>
         </p:txBody>
@@ -4763,7 +4763,7 @@
           </a:p>
           <a:p>
             <a:r>
-              <a:t>历史实验来自固定提交d5e4a71；本轮只重组文稿与执行交付文件检查，不训练或推理官方测试。</a:t>
+              <a:t>科学实验来自固定提交d5e4a71；发布阶段另验固定验证样例与文件，不训练或推理官方测试。</a:t>
             </a:r>
           </a:p>
         </p:txBody>
@@ -4904,7 +4904,7 @@
           </a:p>
           <a:p>
             <a:r>
-              <a:t>历史实验来自固定提交d5e4a71；本轮只重组文稿与执行交付文件检查，不训练或推理官方测试。</a:t>
+              <a:t>科学实验来自固定提交d5e4a71；发布阶段另验固定验证样例与文件，不训练或推理官方测试。</a:t>
             </a:r>
           </a:p>
         </p:txBody>
@@ -39699,7 +39699,7 @@
                 </a:solidFill>
                 <a:latin typeface="Noto Sans CJK SC"/>
               </a:rPr>
-              <a:t>来源：S17–S18；原阶段七真实截图</a:t>
+              <a:t>来源：S17–S18历史截图；S21新副本验收</a:t>
             </a:r>
           </a:p>
         </p:txBody>
@@ -40042,7 +40042,7 @@
                 </a:solidFill>
                 <a:latin typeface="Noto Sans CJK SC"/>
               </a:rPr>
-              <a:t>历史Mac断网记录 ≠ 全平台验收；当前新提交目录的模型与样例还需复制。</a:t>
+              <a:t>11项原资产已补齐并核哈希；新副本Mac验收通过，课堂设备尚待检查。</a:t>
             </a:r>
           </a:p>
         </p:txBody>
@@ -40619,7 +40619,7 @@
                 </a:solidFill>
                 <a:latin typeface="Noto Sans CJK SC"/>
               </a:rPr>
-              <a:t>新教师提交仓库（待上传）</a:t>
+              <a:t>新教师提交仓库（已上传）</a:t>
             </a:r>
           </a:p>
         </p:txBody>
@@ -40803,7 +40803,7 @@
                 </a:solidFill>
                 <a:latin typeface="Noto Sans CJK SC"/>
               </a:rPr>
-              <a:t>仅复制必要证据并记来源；新仓库、Release、云端CI和教师访问需实际完成后确认。</a:t>
+              <a:t>独立私有库和CI已完成；运行资产在新库可取，教师账号权限尚待确认。</a:t>
             </a:r>
           </a:p>
         </p:txBody>
@@ -41675,7 +41675,7 @@
                 </a:solidFill>
                 <a:latin typeface="Noto Sans CJK SC"/>
               </a:rPr>
-              <a:t>CI配置已备，云端待运行</a:t>
+              <a:t>云端CI已通过，仅查文件与算术</a:t>
             </a:r>
           </a:p>
         </p:txBody>
@@ -43003,7 +43003,7 @@
                 </a:solidFill>
                 <a:latin typeface="Noto Sans CJK SC"/>
               </a:rPr>
-              <a:t>新仓库与云端CI尚待发布</a:t>
+              <a:t>教师权限与课堂设备尚待确认</a:t>
             </a:r>
           </a:p>
         </p:txBody>

</xml_diff>

<commit_message>
Complete member roles and publish public teacher submission
</commit_message>
<xml_diff>
--- a/presentation/PathMNIST_AI工程实践汇报_教师提交版.pptx
+++ b/presentation/PathMNIST_AI工程实践汇报_教师提交版.pptx
@@ -760,7 +760,7 @@
           </a:p>
           <a:p>
             <a:r>
-              <a:t>封面标题和副标题表明技术对象与课程方法；姓名沿用用户上传PPT，不推测个人分工。</a:t>
+              <a:t>封面列出王张文皓12615035、赵昱淳12615027、李以祺22615003、朱逸枫12615026；成员分工见第24页。</a:t>
             </a:r>
           </a:p>
           <a:p/>
@@ -2723,7 +2723,7 @@
           </a:p>
           <a:p>
             <a:r>
-              <a:t>说明已完成的独立私有发布，以及仍待确认的教师权限。</a:t>
+              <a:t>说明独立公开仓库的阅读和下载入口。</a:t>
             </a:r>
           </a:p>
           <a:p/>
@@ -2745,7 +2745,7 @@
           </a:p>
           <a:p>
             <a:r>
-              <a:t>独立私有仓库Wenhow1/pathmnist-ai-practice-submission已创建并上传，原仓库保持只读。新库包含报告、PPT、必要代码、证据、模型和固定样例，基本阅读与演示不依赖原私有库权限。真实CI已有通过记录，具体提交与Release见发布回执。教师账号未提供，因此尚未邀请或验收教师访问。</a:t>
+              <a:t>独立教师仓库Wenhow1/pathmnist-ai-practice-submission已上传，并按小组决定公开。原科学仓库保持原权限和只读状态。新库包含报告、PPT、必要代码、证据、模型和固定样例，基本阅读与演示无需原私有库权限，也无需教师账号邀请。真实CI、版本和Release可按发布回执核对。</a:t>
             </a:r>
           </a:p>
           <a:p/>
@@ -2767,7 +2767,7 @@
           </a:p>
           <a:p>
             <a:r>
-              <a:t>问：老师需要原库权限吗？答：基本阅读与演示所需资产已在新库；老师仍需获得新私有库权限并接受邀请。</a:t>
+              <a:t>问：老师需要账号邀请吗？答：教师提交库已公开，可以直接读取与下载；原科学库权限不变。</a:t>
             </a:r>
           </a:p>
           <a:p/>
@@ -3005,7 +3005,7 @@
           </a:p>
           <a:p>
             <a:r>
-              <a:t>清楚说明人的价值而不虚构手写代码比例。</a:t>
+              <a:t>按小组提供的信息呈现四名成员的责任范围。</a:t>
             </a:r>
           </a:p>
           <a:p/>
@@ -3016,7 +3016,7 @@
           </a:p>
           <a:p>
             <a:r>
-              <a:t>四行是方法归纳；不是量化教学效果，不把成员名字绑定未经确认的任务。</a:t>
+              <a:t>左列是姓名和学号，右列是责任范围；按规划、技术实现、测试与交付理解协作。</a:t>
             </a:r>
           </a:p>
           <a:p/>
@@ -3027,7 +3027,7 @@
           </a:p>
           <a:p>
             <a:r>
-              <a:t>我们学到的不是让AI永不出错，而是说清任务、核对证据、限定修复范围并作出取舍。大量实现确实由Codex完成，人的贡献应按真实记录说明。我们没有工时对照，不说效率提升几倍。</a:t>
+              <a:t>王张文皓（12615035）负责代码与技术实现；赵昱淳（12615027）负责项目规划；李以祺（22615003）负责后端测试与代码整理；朱逸枫（12615026）负责云端维护与报告整理。分工依据小组提供的信息；AI参与实现与自动执行按日志如实保留，不将未署名的历史操作归给个人，也不编造工时或贡献比例。</a:t>
             </a:r>
           </a:p>
           <a:p/>
@@ -3049,7 +3049,7 @@
           </a:p>
           <a:p>
             <a:r>
-              <a:t>问：你个人具体做了什么？答：按已记录的任务、决策和本人补充回答，不把AI自动执行写成个人独立完成。</a:t>
+              <a:t>问：代码都是个人手写的吗？答：王张文皓负责技术实现与集成，项目中Codex参与代码生成和执行；团队责任与AI具体作用按日志分别说明。</a:t>
             </a:r>
           </a:p>
           <a:p/>
@@ -3060,7 +3060,7 @@
           </a:p>
           <a:p>
             <a:r>
-              <a:t>S08、S13、S20</a:t>
+              <a:t>S08、S13、S20；2026-10-19小组补充分工</a:t>
             </a:r>
           </a:p>
           <a:p/>
@@ -3168,7 +3168,7 @@
           </a:p>
           <a:p>
             <a:r>
-              <a:t>我们把自然语言需求推进成代码、真实实验、核查和交付，并保留建议被纠正或否决的过程。发布接手补齐原运行资产、验收新副本，创建独立私有库并取得真实CI记录。科学结果没有改变。患者级、全平台、教师账号访问和课堂设备仍保留证据边界。</a:t>
+              <a:t>我们把自然语言需求推进成代码、真实实验、核查和交付，并保留建议被纠正或否决的过程。发布接手补齐原运行资产、验收新副本，独立教师库现已公开并有真实CI记录。科学结果没有改变。患者级、跨平台与临床有效性仍保留证据边界；本次按小组要求提交可打开的PPT及PDF。</a:t>
             </a:r>
           </a:p>
           <a:p/>
@@ -4014,7 +4014,7 @@
           </a:p>
           <a:p>
             <a:r>
-              <a:t>我们能展示实际日志、代码和核验记录；没有证据的Skill和云端运行不列为已完成。新教师目录可以在Codex中接手，复制必要模型样例、创建新私有库并运行检查，原库不变。</a:t>
+              <a:t>可以按阶段日志说明ChatGPT讨论、Codex执行和DeepSeek审查的实际作用。新教师仓库已经公开，含报告、PPT、必要源码、模型及固定样例，并有Release和真实CI记录。基本读取不需要邀请，也不需要原私有仓库权限；原科学实验与结果未改变。</a:t>
             </a:r>
           </a:p>
           <a:p/>
@@ -28492,7 +28492,7 @@
         <p:spPr>
           <a:xfrm>
             <a:off x="1371600" y="5437505"/>
-            <a:ext cx="9418320" cy="295275"/>
+            <a:ext cx="9418320" cy="650000"/>
           </a:xfrm>
           <a:prstGeom prst="rect">
             <a:avLst/>
@@ -28525,19 +28525,29 @@
                 <a:ea typeface="Comic Sans Pro" panose="02010600010101010101" charset="-122"/>
                 <a:cs typeface="Comic Sans Pro" panose="02010600010101010101" charset="-122"/>
               </a:rPr>
-              <a:t>汇报人：</a:t>
-            </a:r>
-            <a:r>
-              <a:rPr lang="zh-CN" sz="1700" b="0">
-                <a:solidFill>
-                  <a:srgbClr val="687583"/>
-                </a:solidFill>
-                <a:latin typeface="Comic Sans Pro" panose="02010600010101010101" charset="-122"/>
-                <a:ea typeface="Comic Sans Pro" panose="02010600010101010101" charset="-122"/>
-                <a:cs typeface="Comic Sans Pro" panose="02010600010101010101" charset="-122"/>
-              </a:rPr>
-              <a:t>王张文皓</a:t>
-            </a:r>
+              <a:t>汇报人：王张文皓（12615035）</a:t>
+            </a:r>
+            <a:endParaRPr lang="zh-CN" altLang="en-US" sz="1700" b="0">
+              <a:solidFill>
+                <a:srgbClr val="687583"/>
+              </a:solidFill>
+              <a:latin typeface="Comic Sans Pro" panose="02010600010101010101" charset="-122"/>
+              <a:ea typeface="Comic Sans Pro" panose="02010600010101010101" charset="-122"/>
+              <a:cs typeface="Comic Sans Pro" panose="02010600010101010101" charset="-122"/>
+            </a:endParaRPr>
+          </a:p>
+          <a:p>
+            <a:pPr algn="ctr">
+              <a:lnSpc>
+                <a:spcPct val="112000"/>
+              </a:lnSpc>
+              <a:spcBef>
+                <a:spcPts val="0"/>
+              </a:spcBef>
+              <a:spcAft>
+                <a:spcPts val="0"/>
+              </a:spcAft>
+            </a:pPr>
             <a:r>
               <a:rPr sz="1700" b="0">
                 <a:solidFill>
@@ -28547,84 +28557,7 @@
                 <a:ea typeface="Comic Sans Pro" panose="02010600010101010101" charset="-122"/>
                 <a:cs typeface="Comic Sans Pro" panose="02010600010101010101" charset="-122"/>
               </a:rPr>
-              <a:t>              </a:t>
-            </a:r>
-            <a:r>
-              <a:rPr lang="en-US" sz="1700" b="0">
-                <a:solidFill>
-                  <a:srgbClr val="687583"/>
-                </a:solidFill>
-                <a:latin typeface="Comic Sans Pro" panose="02010600010101010101" charset="-122"/>
-                <a:ea typeface="Comic Sans Pro" panose="02010600010101010101" charset="-122"/>
-                <a:cs typeface="Comic Sans Pro" panose="02010600010101010101" charset="-122"/>
-              </a:rPr>
-              <a:t>                                         </a:t>
-            </a:r>
-            <a:r>
-              <a:rPr sz="1700" b="0">
-                <a:solidFill>
-                  <a:srgbClr val="687583"/>
-                </a:solidFill>
-                <a:latin typeface="Comic Sans Pro" panose="02010600010101010101" charset="-122"/>
-                <a:ea typeface="Comic Sans Pro" panose="02010600010101010101" charset="-122"/>
-                <a:cs typeface="Comic Sans Pro" panose="02010600010101010101" charset="-122"/>
-              </a:rPr>
-              <a:t>小组：</a:t>
-            </a:r>
-            <a:r>
-              <a:rPr lang="zh-CN" sz="1700" b="0">
-                <a:solidFill>
-                  <a:srgbClr val="687583"/>
-                </a:solidFill>
-                <a:latin typeface="Comic Sans Pro" panose="02010600010101010101" charset="-122"/>
-                <a:ea typeface="Comic Sans Pro" panose="02010600010101010101" charset="-122"/>
-                <a:cs typeface="Comic Sans Pro" panose="02010600010101010101" charset="-122"/>
-              </a:rPr>
-              <a:t>赵昱淳</a:t>
-            </a:r>
-            <a:r>
-              <a:rPr lang="en-US" altLang="zh-CN" sz="1700" b="0">
-                <a:solidFill>
-                  <a:srgbClr val="687583"/>
-                </a:solidFill>
-                <a:latin typeface="Comic Sans Pro" panose="02010600010101010101" charset="-122"/>
-                <a:ea typeface="Comic Sans Pro" panose="02010600010101010101" charset="-122"/>
-                <a:cs typeface="Comic Sans Pro" panose="02010600010101010101" charset="-122"/>
-              </a:rPr>
-              <a:t>      </a:t>
-            </a:r>
-            <a:r>
-              <a:rPr lang="zh-CN" altLang="en-US" sz="1700" b="0">
-                <a:solidFill>
-                  <a:srgbClr val="687583"/>
-                </a:solidFill>
-                <a:latin typeface="Comic Sans Pro" panose="02010600010101010101" charset="-122"/>
-                <a:ea typeface="Comic Sans Pro" panose="02010600010101010101" charset="-122"/>
-                <a:cs typeface="Comic Sans Pro" panose="02010600010101010101" charset="-122"/>
-              </a:rPr>
-              <a:t>李以祺</a:t>
-            </a:r>
-            <a:r>
-              <a:rPr lang="en-US" altLang="zh-CN" sz="1700" b="0">
-                <a:solidFill>
-                  <a:srgbClr val="687583"/>
-                </a:solidFill>
-                <a:latin typeface="Comic Sans Pro" panose="02010600010101010101" charset="-122"/>
-                <a:ea typeface="Comic Sans Pro" panose="02010600010101010101" charset="-122"/>
-                <a:cs typeface="Comic Sans Pro" panose="02010600010101010101" charset="-122"/>
-              </a:rPr>
-              <a:t>      </a:t>
-            </a:r>
-            <a:r>
-              <a:rPr lang="zh-CN" altLang="en-US" sz="1700" b="0">
-                <a:solidFill>
-                  <a:srgbClr val="687583"/>
-                </a:solidFill>
-                <a:latin typeface="Comic Sans Pro" panose="02010600010101010101" charset="-122"/>
-                <a:ea typeface="Comic Sans Pro" panose="02010600010101010101" charset="-122"/>
-                <a:cs typeface="Comic Sans Pro" panose="02010600010101010101" charset="-122"/>
-              </a:rPr>
-              <a:t>朱逸枫</a:t>
+              <a:t>组员：赵昱淳（12615027）　李以祺（22615003）　朱逸枫（12615026）</a:t>
             </a:r>
             <a:endParaRPr lang="zh-CN" altLang="en-US" sz="1700" b="0">
               <a:solidFill>
@@ -40042,7 +39975,7 @@
                 </a:solidFill>
                 <a:latin typeface="Noto Sans CJK SC"/>
               </a:rPr>
-              <a:t>11项原资产已补齐并核哈希；新副本Mac验收通过，课堂设备尚待检查。</a:t>
+              <a:t>11项原资产已补齐并核哈希；新副本Mac验收通过。本次提交PPT与PDF。</a:t>
             </a:r>
           </a:p>
         </p:txBody>
@@ -40619,7 +40552,7 @@
                 </a:solidFill>
                 <a:latin typeface="Noto Sans CJK SC"/>
               </a:rPr>
-              <a:t>新教师提交仓库（已上传）</a:t>
+              <a:t>新教师提交仓库（公开）</a:t>
             </a:r>
           </a:p>
         </p:txBody>
@@ -40718,7 +40651,7 @@
                 </a:solidFill>
                 <a:latin typeface="Noto Sans CJK SC"/>
               </a:rPr>
-              <a:t>独立权限、清楚入口</a:t>
+              <a:t>公开阅读、无需邀请</a:t>
             </a:r>
           </a:p>
         </p:txBody>
@@ -40803,7 +40736,7 @@
                 </a:solidFill>
                 <a:latin typeface="Noto Sans CJK SC"/>
               </a:rPr>
-              <a:t>独立私有库和CI已完成；运行资产在新库可取，教师账号权限尚待确认。</a:t>
+              <a:t>独立公开库与CI已完成；报告、PPT与演示资产可直接读取，无需教师账号。</a:t>
             </a:r>
           </a:p>
         </p:txBody>
@@ -41894,7 +41827,7 @@
                 </a:solidFill>
                 <a:latin typeface="Noto Sans CJK SC"/>
               </a:rPr>
-              <a:t>人的学习：会提任务、会质询、会拒绝不合适的建议</a:t>
+              <a:t>成员分工：规划、实现、测试与交付</a:t>
             </a:r>
           </a:p>
         </p:txBody>
@@ -41979,7 +41912,7 @@
                 </a:solidFill>
                 <a:latin typeface="Noto Sans CJK SC"/>
               </a:rPr>
-              <a:t>来源：S08、S13、S20；个人分工待本人确认</a:t>
+              <a:t>来源：S08、S13、S20；小组补充的成员分工</a:t>
             </a:r>
           </a:p>
         </p:txBody>
@@ -42024,7 +41957,7 @@
                           </a:solidFill>
                           <a:latin typeface="Noto Sans CJK SC"/>
                         </a:rPr>
-                        <a:t>实践收获</a:t>
+                        <a:t>成员与学号</a:t>
                       </a:r>
                     </a:p>
                   </a:txBody>
@@ -42051,7 +41984,7 @@
                           </a:solidFill>
                           <a:latin typeface="Noto Sans CJK SC"/>
                         </a:rPr>
-                        <a:t>在本项目中的表现</a:t>
+                        <a:t>主要责任</a:t>
                       </a:r>
                     </a:p>
                   </a:txBody>
@@ -42080,7 +42013,7 @@
                           </a:solidFill>
                           <a:latin typeface="Noto Sans CJK SC"/>
                         </a:rPr>
-                        <a:t>从目标到任务</a:t>
+                        <a:t>王张文皓 12615035</a:t>
                       </a:r>
                     </a:p>
                   </a:txBody>
@@ -42107,7 +42040,7 @@
                           </a:solidFill>
                           <a:latin typeface="Noto Sans CJK SC"/>
                         </a:rPr>
-                        <a:t>明确输入、范围、产物和验收；不只说“帮我做模型”</a:t>
+                        <a:t>代码与技术实现：数据处理、训练评估、演示集成及问题修复</a:t>
                       </a:r>
                     </a:p>
                   </a:txBody>
@@ -42136,7 +42069,7 @@
                           </a:solidFill>
                           <a:latin typeface="Noto Sans CJK SC"/>
                         </a:rPr>
-                        <a:t>从结果到证据</a:t>
+                        <a:t>赵昱淳 12615027</a:t>
                       </a:r>
                     </a:p>
                   </a:txBody>
@@ -42163,7 +42096,7 @@
                           </a:solidFill>
                           <a:latin typeface="Noto Sans CJK SC"/>
                         </a:rPr>
-                        <a:t>区分自动计算、AI建议和人工决定；知道哈希的边界</a:t>
+                        <a:t>项目规划：需求梳理、方案设计、任务拆解与阶段协调</a:t>
                       </a:r>
                     </a:p>
                   </a:txBody>
@@ -42192,7 +42125,7 @@
                           </a:solidFill>
                           <a:latin typeface="Noto Sans CJK SC"/>
                         </a:rPr>
-                        <a:t>从建议到取舍</a:t>
+                        <a:t>李以祺 22615003</a:t>
                       </a:r>
                     </a:p>
                   </a:txBody>
@@ -42219,7 +42152,7 @@
                           </a:solidFill>
                           <a:latin typeface="Noto Sans CJK SC"/>
                         </a:rPr>
-                        <a:t>早停缺失判断被纠正；DeepSeek草稿未直接采用</a:t>
+                        <a:t>后端测试与代码整理：功能及异常检查、模块与运行说明</a:t>
                       </a:r>
                     </a:p>
                   </a:txBody>
@@ -42248,7 +42181,7 @@
                           </a:solidFill>
                           <a:latin typeface="Noto Sans CJK SC"/>
                         </a:rPr>
-                        <a:t>从一次对话到交付</a:t>
+                        <a:t>朱逸枫 12615026</a:t>
                       </a:r>
                     </a:p>
                   </a:txBody>
@@ -42275,7 +42208,7 @@
                           </a:solidFill>
                           <a:latin typeface="Noto Sans CJK SC"/>
                         </a:rPr>
-                        <a:t>记录版本和未决项，换会话仍能找到依据</a:t>
+                        <a:t>云端维护与报告整理：环境和文件维护、记录图表与提交材料</a:t>
                       </a:r>
                     </a:p>
                   </a:txBody>
@@ -42327,7 +42260,7 @@
                 </a:solidFill>
                 <a:latin typeface="Noto Sans CJK SC"/>
               </a:rPr>
-              <a:t>没有无AI对照或完整工时账本，不编造提效百分比；具体成员贡献由本人填写。</a:t>
+              <a:t>分工依据小组提供的信息；AI辅助实现如实记录，不虚构个人工时或逐条操作署名。</a:t>
             </a:r>
           </a:p>
         </p:txBody>
@@ -43003,7 +42936,7 @@
                 </a:solidFill>
                 <a:latin typeface="Noto Sans CJK SC"/>
               </a:rPr>
-              <a:t>教师权限与课堂设备尚待确认</a:t>
+              <a:t>跨平台和临床有效性未验收</a:t>
             </a:r>
           </a:p>
         </p:txBody>
@@ -47070,7 +47003,7 @@
                           </a:solidFill>
                           <a:latin typeface="Noto Sans CJK SC"/>
                         </a:rPr>
-                        <a:t>本地材料与配置已准备；云端创建、运行、发布及授权仍待执行。</a:t>
+                        <a:t>独立公开库、Release与真实CI已有记录；教师可直接读取，无需邀请。</a:t>
                       </a:r>
                     </a:p>
                   </a:txBody>

</xml_diff>

<commit_message>
Synchronize reports with public delivery evidence and PPT notes
</commit_message>
<xml_diff>
--- a/presentation/PathMNIST_AI工程实践汇报_教师提交版.pptx
+++ b/presentation/PathMNIST_AI工程实践汇报_教师提交版.pptx
@@ -912,7 +912,7 @@
           </a:p>
           <a:p>
             <a:r>
-              <a:t>主要数值由程序从已存预测独立复算，AI再读源码与日志查问题。人决定实验范围和结论表述，但没有人工逐张重新标注全部病理图像。检查通过必须注明对象、输入、环境和限制；几类检查不能合成一句“全部验证”。</a:t>
+              <a:t>主要数值由程序从已存预测独立复算，AI再读源码与日志查问题。人决定实验范围和结论表述，但没有人工逐张重新标注全部病理图像。检查通过必须注明对象、输入、环境和限制；几类检查不能合成一句“全部验证”。成员责任范围已由小组确认；未署名的历史操作不逐项归给个人。</a:t>
             </a:r>
           </a:p>
           <a:p/>
@@ -3298,7 +3298,7 @@
           </a:p>
           <a:p>
             <a:r>
-              <a:t>按钮链接到对应附录，最后有返回入口；本轮检查的是结构目标，原生WPS点击待本人确认。</a:t>
+              <a:t>按钮链接到对应附录，最后有返回入口；已检查的是链接结构目标。原生WPS放映未验收，且不列为本次提交条件。</a:t>
             </a:r>
           </a:p>
           <a:p/>
@@ -3992,7 +3992,7 @@
           </a:p>
           <a:p>
             <a:r>
-              <a:t>避免把已经做的资料整理夸大为云端发布。</a:t>
+              <a:t>说明公开发布、CI与模型运行验收分别完成到什么范围。</a:t>
             </a:r>
           </a:p>
           <a:p/>
@@ -4003,7 +4003,7 @@
           </a:p>
           <a:p>
             <a:r>
-              <a:t>四行对应角色、过程、Skill和新提交状态；发布后若状态改变需用真实记录更新，不预填成功。</a:t>
+              <a:t>四行分别说明核验、DeepSeek、Skill与公开提交状态；以已保存的发布回执和实际运行链接为准。</a:t>
             </a:r>
           </a:p>
           <a:p/>
@@ -4036,7 +4036,7 @@
           </a:p>
           <a:p>
             <a:r>
-              <a:t>问：能否让GPT直接开Codex？答：当前对话没有此动作接口，任务包已备好，需要用户在工作区启动交接。</a:t>
+              <a:t>问：本次由ChatGPT自动新建Codex任务吗？答：本次由ChatGPT整理交接包，用户交给已有Codex会话接手；不是自动新建对话，具体执行与发布以交接记录为准。</a:t>
             </a:r>
           </a:p>
           <a:p/>
@@ -29386,7 +29386,7 @@
                 </a:solidFill>
                 <a:latin typeface="Noto Sans CJK SC"/>
               </a:rPr>
-              <a:t>真实个人贡献待本人确认</a:t>
+              <a:t>成员责任范围已由小组确认</a:t>
             </a:r>
           </a:p>
         </p:txBody>

</xml_diff>